<commit_message>
Slide 3 p99 sparkline; demo runbook v4 (Design A, nothing typed live)
</commit_message>
<xml_diff>
--- a/deck/kubecon-na-2026-v3.pptx
+++ b/deck/kubecon-na-2026-v3.pptx
@@ -8728,63 +8728,30 @@
           </a:p>
         </p:txBody>
       </p:sp>
-      <p:sp>
-        <p:nvSpPr>
-          <p:cNvPr id="3" name="TextBox 2"/>
-          <p:cNvSpPr txBox="1"/>
+      <p:pic>
+        <p:nvPicPr>
+          <p:cNvPr id="3" name="Picture 2" descr="cncf-feedback-qr.png"/>
+          <p:cNvPicPr>
+            <a:picLocks noChangeAspect="1"/>
+          </p:cNvPicPr>
           <p:nvPr/>
-        </p:nvSpPr>
+        </p:nvPicPr>
+        <p:blipFill>
+          <a:blip r:embed="rId3"/>
+          <a:stretch>
+            <a:fillRect/>
+          </a:stretch>
+        </p:blipFill>
         <p:spPr>
           <a:xfrm>
-            <a:off x="9988318" y="4600000"/>
-            <a:ext cx="1800000" cy="1800000"/>
+            <a:off x="10014302" y="4600000"/>
+            <a:ext cx="1748031" cy="1800000"/>
           </a:xfrm>
           <a:prstGeom prst="rect">
             <a:avLst/>
           </a:prstGeom>
-          <a:solidFill>
-            <a:srgbClr val="F3F3F3"/>
-          </a:solidFill>
         </p:spPr>
-        <p:txBody>
-          <a:bodyPr wrap="square" anchor="ctr">
-            <a:spAutoFit/>
-          </a:bodyPr>
-          <a:lstStyle/>
-          <a:p>
-            <a:pPr algn="ctr">
-              <a:spcAft>
-                <a:spcPts val="600"/>
-              </a:spcAft>
-            </a:pPr>
-            <a:r>
-              <a:rPr sz="1400" b="0" i="0">
-                <a:solidFill>
-                  <a:srgbClr val="6B6B6B"/>
-                </a:solidFill>
-                <a:latin typeface="Arial"/>
-              </a:rPr>
-              <a:t>[screenshot: cncf-feedback-qr.png]</a:t>
-            </a:r>
-          </a:p>
-          <a:p>
-            <a:pPr algn="ctr">
-              <a:spcAft>
-                <a:spcPts val="600"/>
-              </a:spcAft>
-            </a:pPr>
-            <a:r>
-              <a:rPr sz="1200" b="0" i="0">
-                <a:solidFill>
-                  <a:srgbClr val="6B6B6B"/>
-                </a:solidFill>
-                <a:latin typeface="Arial"/>
-              </a:rPr>
-              <a:t>CNCF feedback QR</a:t>
-            </a:r>
-          </a:p>
-        </p:txBody>
-      </p:sp>
+      </p:pic>
     </p:spTree>
   </p:cSld>
   <p:clrMapOvr>

</xml_diff>